<commit_message>
Deck revision: history scars, Efron saga, dollar cost anatomy
</commit_message>
<xml_diff>
--- a/docs/presentations/kodiak-creative-automation/kodiak-walkthrough.pptx
+++ b/docs/presentations/kodiak-creative-automation/kodiak-walkthrough.pptx
@@ -517,7 +517,7 @@
           <a:lstStyle/>
           <a:p>
             <a:r>
-              <a:t>Open with the contract: a single campaign brief fans out to every market, ratio, and language. Say plainly: the pipeline never invents brand truth, it stages it.</a:t>
+              <a:t>30-second contract: what it is (one brief fans out to every market, ratio, language), who it is for (Maya, Diego, Priya), what good looks like (launch-ready in 10 min; the model never invents brand truth).</a:t>
             </a:r>
           </a:p>
         </p:txBody>
@@ -587,7 +587,7 @@
           <a:lstStyle/>
           <a:p>
             <a:r>
-              <a:t>Tell the cost story honestly: the $38/day lesson is why cache plus run-to-completion plus voice-flag-off are defaults, not options.</a:t>
+              <a:t>Tell the cost story honestly: a full incident day 2026-09-23, six hardening commits (4575cfd cost stop, ac62017 voice gate, 0172e2d hardening, 351f6c2 prewarm deleted, 6c25386 IAM narrow, bdfa2e3 inference profile). Everything expensive is off by default with per-request opt-in; that is why cache plus run-to-completion plus voice-flag-off are defaults, not options. Dollar anatomy: about $0.07 per tile, about $1.18 per full 13-tile set; September warm-time $245 dwarfed about $17 of image spend; a public gate would bill $1.18 per run times traffic.</a:t>
             </a:r>
           </a:p>
         </p:txBody>
@@ -657,7 +657,7 @@
           <a:lstStyle/>
           <a:p>
             <a:r>
-              <a:t>Frame limits as design: the static host stays dumb and fast, the API does the thinking, and copy law means a missing translation degrades loudly.</a:t>
+              <a:t>Frame limits as design: the static host stays dumb and fast, the API does the thinking, and copy law means a missing translation degrades loudly. Scar: brooklyn idea-honesty night (5839df7), copy named the idea while pixels went generic with 1 suite failure unidentified at ship; now _brief_idea harvests ecology and unmatched ideas paint a B0 original. Demo shows graceful degradation, never silent invention.</a:t>
             </a:r>
           </a:p>
         </p:txBody>
@@ -867,7 +867,7 @@
           <a:lstStyle/>
           <a:p>
             <a:r>
-              <a:t>Anchor on the cache win: repeat renders stop paying Bedrock twice. Name what is live versus pending so the room trusts the board.</a:t>
+              <a:t>Anchor on the cache win with the baseline beside it: before, every repeat render paid Bedrock again; after, cache-hit repeats pay 0 invokes, live hit-rate pending (#308) so the claim stays honest. Production-today close: cache counter code-done in main, RUM monitor live; Canvas proof (#51) and Llama re-import stay stated-open, not promised.</a:t>
             </a:r>
           </a:p>
         </p:txBody>
@@ -1007,7 +1007,7 @@
           <a:lstStyle/>
           <a:p>
             <a:r>
-              <a:t>End on the invitation: one runnable command, one reading path, one question back to the room. Thank them and take questions.</a:t>
+              <a:t>End on the invitation: one runnable command, one reading path, one question back to the room. The reviewer ZIP START-HERE.html is the one-pager: live URL, one runnable command, reading path, and the dead-venue fallback. Thank them and take questions.</a:t>
             </a:r>
           </a:p>
         </p:txBody>
@@ -1077,7 +1077,7 @@
           <a:lstStyle/>
           <a:p>
             <a:r>
-              <a:t>Demo the resting page first with no clicks: five export sizes plus baked EN/ES/PT copy prove offline-first before any generate call.</a:t>
+              <a:t>Demo the resting page first with no clicks: five export sizes plus baked EN/ES/PT copy prove offline-first before any generate call. Fallback per demo: if generate dies, the resting render still proves offline-first; the reviewer ZIP is the dead-venue equivalent (slide 12).</a:t>
             </a:r>
           </a:p>
         </p:txBody>
@@ -1217,7 +1217,7 @@
           <a:lstStyle/>
           <a:p>
             <a:r>
-              <a:t>Caveat on stage: persona docs say 23 baselines but the file holds 503 rows. Reframe as 23 heroes plus hundreds of localized drafts until docs are fixed.</a:t>
+              <a:t>Caveat on stage: persona docs say 23 baselines but the file holds 503 rows. Reframe as 23 heroes plus hundreds of localized drafts until docs are fixed; the card stays flagged pending, single-sourced.</a:t>
             </a:r>
           </a:p>
         </p:txBody>
@@ -1287,7 +1287,7 @@
           <a:lstStyle/>
           <a:p>
             <a:r>
-              <a:t>Trace tokens to pixels live: kodiak.json is the source of truth, compose draws layout, compliance votes pass or fail. The model never touches logo or type.</a:t>
+              <a:t>Trace tokens to pixels live: kodiak.json is the source of truth, compose draws layout, compliance votes pass or fail. The model never touches logo or type. Efron beat (gh#251, Sep 4-8): ingested partner-libraries.json with licensed-only DAM keys plus two shot-list gaps; refusal had two faces, a silent generic stack while the receipt claimed the theme, and a hard filter trip on raw real-person names (scene_prompts.py:85-95, generate_lambda.py:2433); removal Sep 8 (3505de8, 16 files, +177/-553) after 4-5 days build-then-remove plus hardening (02ada6b, 0d79c5d); no per-theme dollar ledger exists. Survived as law: no named-person themes, retired-name scrub, match-or-abstain theme-mismatch flag, bear law, mascot-lock identity pattern.</a:t>
             </a:r>
           </a:p>
         </p:txBody>
@@ -1497,7 +1497,7 @@
           <a:lstStyle/>
           <a:p>
             <a:r>
-              <a:t>Stress the contract: same JSON in CLI, API, and MCP. Callable or not shippable; no mock-as-success anywhere on this surface.</a:t>
+              <a:t>Stress the contract: same JSON in CLI, API, and MCP. Callable or not shippable; no mock-as-success anywhere on this surface. Scar: bespoke art surfaces rotted and were cut (art band ed785f1, frontier collapsed to one screen plus gated 3d marquee 3f71087); shared forest cap and static fallback remain.</a:t>
             </a:r>
           </a:p>
         </p:txBody>
@@ -1567,7 +1567,7 @@
           <a:lstStyle/>
           <a:p>
             <a:r>
-              <a:t>Make the tradeoff explicit: the Gateway cap is fixed, so preview buys immediacy and jobs buy completeness. Never hold a sync call past the wall.</a:t>
+              <a:t>Make the tradeoff explicit: the Gateway cap is fixed, so preview buys immediacy and jobs buy completeness. Scar: prod fell through to the brand floor on a cold-model serial chain past the 22s wall, so the wall went gateway-correct 26s (0147071); never hold a sync call past the wall.</a:t>
             </a:r>
           </a:p>
         </p:txBody>

</xml_diff>

<commit_message>
Lock deck for presentation: drop whats-next, 15 slides, close ends it
</commit_message>
<xml_diff>
--- a/docs/presentations/kodiak-creative-automation/kodiak-walkthrough.pptx
+++ b/docs/presentations/kodiak-creative-automation/kodiak-walkthrough.pptx
@@ -20,7 +20,6 @@
     <p:sldId id="268" r:id="rId20"/>
     <p:sldId id="269" r:id="rId21"/>
     <p:sldId id="270" r:id="rId22"/>
-    <p:sldId id="271" r:id="rId23"/>
   </p:sldIdLst>
   <p:sldSz cx="12191695" cy="6858000" type="screen4x3"/>
   <p:notesSz cx="6858000" cy="9144000"/>
@@ -893,76 +892,6 @@
 </file>
 
 <file path=ppt/notesSlides/notesSlide15.xml><?xml version="1.0" encoding="utf-8"?>
-<p:notes xmlns:a="http://schemas.openxmlformats.org/drawingml/2006/main" xmlns:p="http://schemas.openxmlformats.org/presentationml/2006/main" xmlns:r="http://schemas.openxmlformats.org/officeDocument/2006/relationships">
-  <p:cSld>
-    <p:spTree>
-      <p:nvGrpSpPr>
-        <p:cNvPr id="1" name=""/>
-        <p:cNvGrpSpPr/>
-        <p:nvPr/>
-      </p:nvGrpSpPr>
-      <p:grpSpPr>
-        <a:xfrm>
-          <a:off x="0" y="0"/>
-          <a:ext cx="0" cy="0"/>
-          <a:chOff x="0" y="0"/>
-          <a:chExt cx="0" cy="0"/>
-        </a:xfrm>
-      </p:grpSpPr>
-      <p:sp>
-        <p:nvSpPr>
-          <p:cNvPr id="2" name="Slide Image Placeholder 1"/>
-          <p:cNvSpPr>
-            <a:spLocks noGrp="1"/>
-          </p:cNvSpPr>
-          <p:nvPr>
-            <p:ph type="sldImg" idx="2"/>
-          </p:nvPr>
-        </p:nvSpPr>
-        <p:spPr/>
-      </p:sp>
-      <p:sp>
-        <p:nvSpPr>
-          <p:cNvPr id="3" name="Notes Placeholder 2"/>
-          <p:cNvSpPr>
-            <a:spLocks noGrp="1"/>
-          </p:cNvSpPr>
-          <p:nvPr>
-            <p:ph type="body" idx="3" sz="quarter"/>
-          </p:nvPr>
-        </p:nvSpPr>
-        <p:spPr/>
-        <p:txBody>
-          <a:bodyPr/>
-          <a:lstStyle/>
-          <a:p>
-            <a:r>
-              <a:t>Close the loop to the backlog: every next item names its issue number. Blocked means blocked, with the rights reason stated, not hidden.</a:t>
-            </a:r>
-          </a:p>
-        </p:txBody>
-      </p:sp>
-      <p:sp>
-        <p:nvSpPr>
-          <p:cNvPr id="4" name="Slide Number Placeholder 3"/>
-          <p:cNvSpPr>
-            <a:spLocks noGrp="1"/>
-          </p:cNvSpPr>
-          <p:nvPr>
-            <p:ph type="sldNum" idx="5" sz="quarter"/>
-          </p:nvPr>
-        </p:nvSpPr>
-        <p:spPr/>
-      </p:sp>
-    </p:spTree>
-  </p:cSld>
-  <p:clrMapOvr>
-    <a:masterClrMapping/>
-  </p:clrMapOvr>
-</p:notes>
-</file>
-
-<file path=ppt/notesSlides/notesSlide16.xml><?xml version="1.0" encoding="utf-8"?>
 <p:notes xmlns:a="http://schemas.openxmlformats.org/drawingml/2006/main" xmlns:p="http://schemas.openxmlformats.org/presentationml/2006/main" xmlns:r="http://schemas.openxmlformats.org/officeDocument/2006/relationships">
   <p:cSld>
     <p:spTree>
@@ -4828,48 +4757,6 @@
       <p:pic>
         <p:nvPicPr>
           <p:cNvPr id="2" name="Picture 1" descr="s15.png"/>
-          <p:cNvPicPr>
-            <a:picLocks noChangeAspect="1"/>
-          </p:cNvPicPr>
-          <p:nvPr/>
-        </p:nvPicPr>
-        <p:blipFill>
-          <a:blip r:embed="rId2"/>
-          <a:stretch>
-            <a:fillRect/>
-          </a:stretch>
-        </p:blipFill>
-        <p:spPr>
-          <a:xfrm>
-            <a:off x="0" y="0"/>
-            <a:ext cx="12191695" cy="6858000"/>
-          </a:xfrm>
-          <a:prstGeom prst="rect">
-            <a:avLst/>
-          </a:prstGeom>
-        </p:spPr>
-      </p:pic>
-    </p:spTree>
-  </p:cSld>
-  <p:clrMapOvr>
-    <a:masterClrMapping/>
-  </p:clrMapOvr>
-</p:sld>
-</file>
-
-<file path=ppt/slides/slide16.xml><?xml version="1.0" encoding="utf-8"?>
-<p:sld xmlns:a="http://schemas.openxmlformats.org/drawingml/2006/main" xmlns:p="http://schemas.openxmlformats.org/presentationml/2006/main" xmlns:r="http://schemas.openxmlformats.org/officeDocument/2006/relationships">
-  <p:cSld>
-    <p:spTree>
-      <p:nvGrpSpPr>
-        <p:cNvPr id="1" name=""/>
-        <p:cNvGrpSpPr/>
-        <p:nvPr/>
-      </p:nvGrpSpPr>
-      <p:grpSpPr/>
-      <p:pic>
-        <p:nvPicPr>
-          <p:cNvPr id="2" name="Picture 1" descr="s16.png"/>
           <p:cNvPicPr>
             <a:picLocks noChangeAspect="1"/>
           </p:cNvPicPr>

</xml_diff>

<commit_message>
Deck adversarial pass: roles not names, Park City only, client intro, stand-alone slides, dollar truth
</commit_message>
<xml_diff>
--- a/docs/presentations/kodiak-creative-automation/kodiak-walkthrough.pptx
+++ b/docs/presentations/kodiak-creative-automation/kodiak-walkthrough.pptx
@@ -516,7 +516,7 @@
           <a:lstStyle/>
           <a:p>
             <a:r>
-              <a:t>30-second contract: what it is (one brief fans out to every market, ratio, language), who it is for (Maya, Diego, Priya), what good looks like (launch-ready in 10 min; the model never invents brand truth).</a:t>
+              <a:t>30-second contract: what it is (one brief fans out to every market, ratio, language), who it is for (the brand manager, the field ambassador, the performance lead), what good looks like (launch-ready in 10 min; the model never invents brand truth).</a:t>
             </a:r>
           </a:p>
         </p:txBody>
@@ -586,7 +586,7 @@
           <a:lstStyle/>
           <a:p>
             <a:r>
-              <a:t>Tell the cost story honestly: a full incident day 2026-09-23, six hardening commits (4575cfd cost stop, ac62017 voice gate, 0172e2d hardening, 351f6c2 prewarm deleted, 6c25386 IAM narrow, bdfa2e3 inference profile). Everything expensive is off by default with per-request opt-in; that is why cache plus run-to-completion plus voice-flag-off are defaults, not options. Dollar anatomy: about $0.07 per tile, about $1.18 per full 13-tile set; September warm-time $245 dwarfed about $17 of image spend; a public gate would bill $1.18 per run times traffic.</a:t>
+              <a:t>Tell the cost story honestly: a full incident day 2026-09-23, six hardening commits (4575cfd cost stop, ac62017 voice gate, 0172e2d hardening, 351f6c2 prewarm deleted, 6c25386 IAM narrow, bdfa2e3 inference profile). Everything expensive is off by default with per-request opt-in; that is why cache plus run-to-completion plus voice-flag-off are defaults, not options. Dollar anatomy: about $0.07 per tile, about $1.18 per full 13-tile set; September warm-time $245 dwarfed about $17 of image spend; a public gate would bill $1.18 per run times traffic. Two repo figures, different mechanisms: $38/day pre-warm estimate (generate-stack.ts:343-348), $82.34/day art-director copy-minute billing (art_director.py:53-55).</a:t>
             </a:r>
           </a:p>
         </p:txBody>
@@ -656,7 +656,7 @@
           <a:lstStyle/>
           <a:p>
             <a:r>
-              <a:t>Frame limits as design: the static host stays dumb and fast, the API does the thinking, and copy law means a missing translation degrades loudly. Scar: brooklyn idea-honesty night (5839df7), copy named the idea while pixels went generic with 1 suite failure unidentified at ship; now _brief_idea harvests ecology and unmatched ideas paint a B0 original. Demo shows graceful degradation, never silent invention.</a:t>
+              <a:t>Frame limits as design: the static host stays dumb and fast, the API does the thinking, and copy law means a missing translation degrades loudly. Scar: idea-honesty night (5839df7), copy named the idea while pixels went generic with 1 suite failure unidentified at ship; now _brief_idea harvests ecology and unmatched ideas paint a B0 original (the text-to-image original rung for no-seed briefs, never a fallback restyle). Demo shows graceful degradation, never silent invention.</a:t>
             </a:r>
           </a:p>
         </p:txBody>
@@ -726,7 +726,7 @@
           <a:lstStyle/>
           <a:p>
             <a:r>
-              <a:t>Hand reviewers a box that works in a dead venue: launcher, docs, code, video. The send/get ledger shows exactly what was sent and what came back.</a:t>
+              <a:t>Hand reviewers a box that works in a dead venue: launcher, docs, code, video. The send/get ledger shows exactly what was sent and what came back (67 tries, 22 approved, 45 rejected-retry).</a:t>
             </a:r>
           </a:p>
         </p:txBody>
@@ -866,7 +866,7 @@
           <a:lstStyle/>
           <a:p>
             <a:r>
-              <a:t>Anchor on the cache win with the baseline beside it: before, every repeat render paid Bedrock again; after, cache-hit repeats pay 0 invokes, live hit-rate pending (#308) so the claim stays honest. Production-today close: cache counter code-done in main, RUM monitor live; Canvas proof (#51) and Llama re-import stay stated-open, not promised.</a:t>
+              <a:t>Anchor on the cache win with the baseline beside it: before, every repeat render paid Bedrock again; after, cache-hit repeats pay 0 invokes, live hit-rate pending (#308) so the claim stays honest. Production-today close: cache counter code-done in main, RUM monitor live; Canvas proof (#51) and Llama re-import stay stated-open, not promised. All numbers tracked in session-work/2026-09-30-backlog/inventory.md.</a:t>
             </a:r>
           </a:p>
         </p:txBody>
@@ -1006,7 +1006,7 @@
           <a:lstStyle/>
           <a:p>
             <a:r>
-              <a:t>Demo the resting page first with no clicks: five export sizes plus baked EN/ES/PT copy prove offline-first before any generate call. Fallback per demo: if generate dies, the resting render still proves offline-first; the reviewer ZIP is the dead-venue equivalent (slide 12).</a:t>
+              <a:t>Demo the resting page first with no clicks: five export sizes plus baked EN/ES/PT copy prove offline-first before any generate call. Fallback per demo: if generate dies, the resting render still proves offline-first; the reviewer ZIP is the dead-venue equivalent covered later in the talk.</a:t>
             </a:r>
           </a:p>
         </p:txBody>
@@ -1076,7 +1076,7 @@
           <a:lstStyle/>
           <a:p>
             <a:r>
-              <a:t>Walk the weekly loop: Maya writes Monday, Diego shares, Priya watches taps, Friday the win becomes a training row the next run suggests first.</a:t>
+              <a:t>Walk the weekly loop: the brand manager writes Monday, the field ambassador shares, the performance lead watches taps, Friday the win becomes a training row the next run suggests first.</a:t>
             </a:r>
           </a:p>
         </p:txBody>
@@ -1146,7 +1146,7 @@
           <a:lstStyle/>
           <a:p>
             <a:r>
-              <a:t>Caveat on stage: persona docs say 23 baselines but the file holds 503 rows. Reframe as 23 heroes plus hundreds of localized drafts until docs are fixed; the card stays flagged pending, single-sourced.</a:t>
+              <a:t>Caveat on stage: persona docs say 23 baselines but the file holds 503 rows. Reframe as 23 hero originals plus hundreds of localized drafts until docs are fixed.</a:t>
             </a:r>
           </a:p>
         </p:txBody>
@@ -1216,7 +1216,7 @@
           <a:lstStyle/>
           <a:p>
             <a:r>
-              <a:t>Trace tokens to pixels live: kodiak.json is the source of truth, compose draws layout, compliance votes pass or fail. The model never touches logo or type. Efron beat (gh#251, Sep 4-8): ingested partner-libraries.json with licensed-only DAM keys plus two shot-list gaps; refusal had two faces, a silent generic stack while the receipt claimed the theme, and a hard filter trip on raw real-person names (scene_prompts.py:85-95, generate_lambda.py:2433); removal Sep 8 (3505de8, 16 files, +177/-553) after 4-5 days build-then-remove plus hardening (02ada6b, 0d79c5d); no per-theme dollar ledger exists. Survived as law: no named-person themes, retired-name scrub, match-or-abstain theme-mismatch flag, bear law, mascot-lock identity pattern.</a:t>
+              <a:t>Trace tokens to pixels live: kodiak.json is the source of truth, compose draws layout, compliance votes pass or fail. The model never touches logo or type. Efron beat (gh#251, Sep 4-8): ingested partner-libraries.json with a licensed-only digital asset library (DAM, the private art bucket) photo policy, two approved shoot keys, and two shot-list gaps; refusal had two faces, a silent generic stack while the receipt claimed the theme, and a hard filter trip on raw real-person names (scene_prompts.py:85-95, generate_lambda.py:2433); removal Sep 8 (3505de8, 16 files, +177/-553) after 4-5 days build-then-remove plus hardening (02ada6b, 0d79c5d); no per-theme dollar ledger exists. Survived as law: no named-person themes, retired-name scrub, match-or-abstain (use the approved photo or use none) with the theme-mismatch flag, bear law, mascot-lock identity pattern.</a:t>
             </a:r>
           </a:p>
         </p:txBody>
@@ -1286,7 +1286,7 @@
           <a:lstStyle/>
           <a:p>
             <a:r>
-              <a:t>Emphasize the ladder: rung D is a deterministic brand floor, so generate never fails open. Nova Canvas is legacy-flagged; the proof run is still open (#51).</a:t>
+              <a:t>Emphasize the ladder: rung D is a deterministic brand floor, so generate always returns a finished tile and never fails open with an error. Nova Canvas is legacy-flagged; the proof run is still open (#51).</a:t>
             </a:r>
           </a:p>
         </p:txBody>
@@ -1356,7 +1356,7 @@
           <a:lstStyle/>
           <a:p>
             <a:r>
-              <a:t>Read the map left to right: static site, path-behavior fan-out, container Lambda, DAM plus tables plus vectors. Pre-warm was removed after the $38/day incident.</a:t>
+              <a:t>Read the map left to right: static site, path-behavior fan-out, container Lambda, DAM plus tables plus vectors. Pre-warm was removed after the ~$38/day imported-model incident (lower of two unreconciled repo figures; range $38-82/day).</a:t>
             </a:r>
           </a:p>
         </p:txBody>
@@ -1426,7 +1426,7 @@
           <a:lstStyle/>
           <a:p>
             <a:r>
-              <a:t>Stress the contract: same JSON in CLI, API, and MCP. Callable or not shippable; no mock-as-success anywhere on this surface. Scar: bespoke art surfaces rotted and were cut (art band ed785f1, frontier collapsed to one screen plus gated 3d marquee 3f71087); shared forest cap and static fallback remain.</a:t>
+              <a:t>Stress the contract: same JSON in CLI, API, and MCP. Callable or not shippable; no mock-as-success anywhere on this surface. Scar (cut-after-rot incident note): bespoke art surfaces rotted and were cut (art band ed785f1, frontier collapsed to one screen plus gated 3d marquee 3f71087); shared forest cap and static fallback remain.</a:t>
             </a:r>
           </a:p>
         </p:txBody>

</xml_diff>

<commit_message>
Deck round two: measured design pass, stranger fixes, code-tour cut to handout
</commit_message>
<xml_diff>
--- a/docs/presentations/kodiak-creative-automation/kodiak-walkthrough.pptx
+++ b/docs/presentations/kodiak-creative-automation/kodiak-walkthrough.pptx
@@ -19,7 +19,6 @@
     <p:sldId id="267" r:id="rId19"/>
     <p:sldId id="268" r:id="rId20"/>
     <p:sldId id="269" r:id="rId21"/>
-    <p:sldId id="270" r:id="rId22"/>
   </p:sldIdLst>
   <p:sldSz cx="12191695" cy="6858000" type="screen4x3"/>
   <p:notesSz cx="6858000" cy="9144000"/>
@@ -516,7 +515,7 @@
           <a:lstStyle/>
           <a:p>
             <a:r>
-              <a:t>30-second contract: what it is (one brief fans out to every market, ratio, language), who it is for (the brand manager, the field ambassador, the performance lead), what good looks like (launch-ready in 10 min; the model never invents brand truth).</a:t>
+              <a:t>30-second contract: what it is (one brief fans out to every market, ratio, language), what good looks like (launch-ready in 10 min; the model never invents brand truth). Roles preview cut; S03 introduces the three roles.</a:t>
             </a:r>
           </a:p>
         </p:txBody>
@@ -586,7 +585,7 @@
           <a:lstStyle/>
           <a:p>
             <a:r>
-              <a:t>Tell the cost story honestly: a full incident day 2026-09-23, six hardening commits (4575cfd cost stop, ac62017 voice gate, 0172e2d hardening, 351f6c2 prewarm deleted, 6c25386 IAM narrow, bdfa2e3 inference profile). Everything expensive is off by default with per-request opt-in; that is why cache plus run-to-completion plus voice-flag-off are defaults, not options. Dollar anatomy: about $0.07 per tile, about $1.18 per full 13-tile set; September warm-time $245 dwarfed about $17 of image spend; a public gate would bill $1.18 per run times traffic. Two repo figures, different mechanisms: $38/day pre-warm estimate (generate-stack.ts:343-348), $82.34/day art-director copy-minute billing (art_director.py:53-55).</a:t>
+              <a:t>Tell the cost story honestly: a full incident day 2026-09-23, six hardening commits (4575cfd cost stop, ac62017 voice gate, 0172e2d hardening, 351f6c2 prewarm deleted, 6c25386 IAM narrow, bdfa2e3 inference profile). Everything expensive is off by default with per-request opt-in. September ledger ($245 warm-time vs $17 image spend) and Canvas proof (#51) in notes; gate billing rides on the S02 demo-pass definition.</a:t>
             </a:r>
           </a:p>
         </p:txBody>
@@ -656,7 +655,7 @@
           <a:lstStyle/>
           <a:p>
             <a:r>
-              <a:t>Frame limits as design: the static host stays dumb and fast, the API does the thinking, and copy law means a missing translation degrades loudly. Scar: idea-honesty night (5839df7), copy named the idea while pixels went generic with 1 suite failure unidentified at ship; now _brief_idea harvests ecology and unmatched ideas paint a B0 original (the text-to-image original rung for no-seed briefs, never a fallback restyle). Demo shows graceful degradation, never silent invention.</a:t>
+              <a:t>Frame limits as design: the static host stays dumb and fast, the API does the thinking, and copy law means a missing translation degrades loudly. Upload live PR#48, orchestration pending inside epic #37. Demo graceful degradation live, never silent invention. Transition: hand them the box. Run: open START-HERE.html.</a:t>
             </a:r>
           </a:p>
         </p:txBody>
@@ -726,7 +725,7 @@
           <a:lstStyle/>
           <a:p>
             <a:r>
-              <a:t>Hand reviewers a box that works in a dead venue: launcher, docs, code, video. The send/get ledger shows exactly what was sent and what came back (67 tries, 22 approved, 45 rejected-retry).</a:t>
+              <a:t>Hand reviewers a box that works in a dead venue: launcher, docs, code, video. The send/get ledger shows exactly what was sent and what came back. Doc-site builder detail in notes. Transition: what landed this week. Run: open the review ledger.</a:t>
             </a:r>
           </a:p>
         </p:txBody>
@@ -796,7 +795,7 @@
           <a:lstStyle/>
           <a:p>
             <a:r>
-              <a:t>Give the reading order, not the whole tree: pipeline first, then generate, compose, localize, retailers. Doc-as-code headers in compose say the contract.</a:t>
+              <a:t>Anchor on the cache win with the baseline beside it: before, every repeat render paid Bedrock again; after, cache-hit repeats pay 0 invokes, live hit-rate pending (#308) so the claim stays honest. Canvas proof (#51) and RUM snippet stay stated-open in the handout, not promised. All numbers tracked in session-work/2026-09-30-backlog/inventory.md. Transition: the invitation. Run: questions.</a:t>
             </a:r>
           </a:p>
         </p:txBody>
@@ -866,77 +865,7 @@
           <a:lstStyle/>
           <a:p>
             <a:r>
-              <a:t>Anchor on the cache win with the baseline beside it: before, every repeat render paid Bedrock again; after, cache-hit repeats pay 0 invokes, live hit-rate pending (#308) so the claim stays honest. Production-today close: cache counter code-done in main, RUM monitor live; Canvas proof (#51) and Llama re-import stay stated-open, not promised. All numbers tracked in session-work/2026-09-30-backlog/inventory.md.</a:t>
-            </a:r>
-          </a:p>
-        </p:txBody>
-      </p:sp>
-      <p:sp>
-        <p:nvSpPr>
-          <p:cNvPr id="4" name="Slide Number Placeholder 3"/>
-          <p:cNvSpPr>
-            <a:spLocks noGrp="1"/>
-          </p:cNvSpPr>
-          <p:nvPr>
-            <p:ph type="sldNum" idx="5" sz="quarter"/>
-          </p:nvPr>
-        </p:nvSpPr>
-        <p:spPr/>
-      </p:sp>
-    </p:spTree>
-  </p:cSld>
-  <p:clrMapOvr>
-    <a:masterClrMapping/>
-  </p:clrMapOvr>
-</p:notes>
-</file>
-
-<file path=ppt/notesSlides/notesSlide15.xml><?xml version="1.0" encoding="utf-8"?>
-<p:notes xmlns:a="http://schemas.openxmlformats.org/drawingml/2006/main" xmlns:p="http://schemas.openxmlformats.org/presentationml/2006/main" xmlns:r="http://schemas.openxmlformats.org/officeDocument/2006/relationships">
-  <p:cSld>
-    <p:spTree>
-      <p:nvGrpSpPr>
-        <p:cNvPr id="1" name=""/>
-        <p:cNvGrpSpPr/>
-        <p:nvPr/>
-      </p:nvGrpSpPr>
-      <p:grpSpPr>
-        <a:xfrm>
-          <a:off x="0" y="0"/>
-          <a:ext cx="0" cy="0"/>
-          <a:chOff x="0" y="0"/>
-          <a:chExt cx="0" cy="0"/>
-        </a:xfrm>
-      </p:grpSpPr>
-      <p:sp>
-        <p:nvSpPr>
-          <p:cNvPr id="2" name="Slide Image Placeholder 1"/>
-          <p:cNvSpPr>
-            <a:spLocks noGrp="1"/>
-          </p:cNvSpPr>
-          <p:nvPr>
-            <p:ph type="sldImg" idx="2"/>
-          </p:nvPr>
-        </p:nvSpPr>
-        <p:spPr/>
-      </p:sp>
-      <p:sp>
-        <p:nvSpPr>
-          <p:cNvPr id="3" name="Notes Placeholder 2"/>
-          <p:cNvSpPr>
-            <a:spLocks noGrp="1"/>
-          </p:cNvSpPr>
-          <p:nvPr>
-            <p:ph type="body" idx="3" sz="quarter"/>
-          </p:nvPr>
-        </p:nvSpPr>
-        <p:spPr/>
-        <p:txBody>
-          <a:bodyPr/>
-          <a:lstStyle/>
-          <a:p>
-            <a:r>
-              <a:t>End on the invitation: one runnable command, one reading path, one question back to the room. The reviewer ZIP START-HERE.html is the one-pager: live URL, one runnable command, reading path, and the dead-venue fallback. Thank them and take questions.</a:t>
+              <a:t>End on the S01 promise kept, not on ports and paths. The reviewer ZIP START-HERE.html is the one-pager: live URL, one runnable command, reading path, and the dead-venue fallback. Reading path lives on the handout only. Thank them and take questions. Run: questions.</a:t>
             </a:r>
           </a:p>
         </p:txBody>
@@ -1006,7 +935,7 @@
           <a:lstStyle/>
           <a:p>
             <a:r>
-              <a:t>Demo the resting page first with no clicks: five export sizes plus baked EN/ES/PT copy prove offline-first before any generate call. Fallback per demo: if generate dies, the resting render still proves offline-first; the reviewer ZIP is the dead-venue equivalent covered later in the talk.</a:t>
+              <a:t>Demo the resting page first with no clicks: five export sizes plus baked EN/ES/PT copy prove offline-first before any generate call. Fallback per demo: if generate dies, the resting render still proves offline-first; name the reviewer ZIP as the take-home that works with no wifi. Gate defined on-slide: a demo pass is a courtesy screen, not a password.</a:t>
             </a:r>
           </a:p>
         </p:txBody>
@@ -1146,7 +1075,7 @@
           <a:lstStyle/>
           <a:p>
             <a:r>
-              <a:t>Caveat on stage: persona docs say 23 baselines but the file holds 503 rows. Reframe as 23 hero originals plus hundreds of localized drafts until docs are fixed.</a:t>
+              <a:t>Caveat on stage: persona docs say 23 baselines but the file holds 503 rows. Reframe as 23 hero originals plus hundreds of localized drafts until docs are fixed. Census percentages (US Census ACS) drive the three copy variants per market.</a:t>
             </a:r>
           </a:p>
         </p:txBody>
@@ -1216,7 +1145,7 @@
           <a:lstStyle/>
           <a:p>
             <a:r>
-              <a:t>Trace tokens to pixels live: kodiak.json is the source of truth, compose draws layout, compliance votes pass or fail. The model never touches logo or type. Efron beat (gh#251, Sep 4-8): ingested partner-libraries.json with a licensed-only digital asset library (DAM, the private art bucket) photo policy, two approved shoot keys, and two shot-list gaps; refusal had two faces, a silent generic stack while the receipt claimed the theme, and a hard filter trip on raw real-person names (scene_prompts.py:85-95, generate_lambda.py:2433); removal Sep 8 (3505de8, 16 files, +177/-553) after 4-5 days build-then-remove plus hardening (02ada6b, 0d79c5d); no per-theme dollar ledger exists. Survived as law: no named-person themes, retired-name scrub, match-or-abstain (use the approved photo or use none) with the theme-mismatch flag, bear law, mascot-lock identity pattern.</a:t>
+              <a:t>Trace tokens to pixels live: kodiak.json is the source of truth, compose draws layout, compliance votes pass or fail. The model never touches logo or type. Refusal history (gh#251, Sep 4-8, removal Sep 8) lives in notes only; surviving law: no named-person themes, retired-name scrub, match-or-abstain with the theme-mismatch flag, bear law, mascot-lock identity pattern.</a:t>
             </a:r>
           </a:p>
         </p:txBody>
@@ -1286,7 +1215,7 @@
           <a:lstStyle/>
           <a:p>
             <a:r>
-              <a:t>Emphasize the ladder: rung D is a deterministic brand floor, so generate always returns a finished tile and never fails open with an error. Nova Canvas is legacy-flagged; the proof run is still open (#51).</a:t>
+              <a:t>Emphasize the ladder: rung D is a guaranteed fallback tile, so generate always returns a finished tile and never fails open with an error. Outputs per run (report.json plus jsonl plus preview.html) and the localize chain (Nova Micro, Translate, offline dict, tagged fallback) in notes. Nova Canvas is legacy-flagged; the proof run is still open (#51).</a:t>
             </a:r>
           </a:p>
         </p:txBody>
@@ -1356,7 +1285,7 @@
           <a:lstStyle/>
           <a:p>
             <a:r>
-              <a:t>Read the map left to right: static site, path-behavior fan-out, container Lambda, DAM plus tables plus vectors. Pre-warm was removed after the ~$38/day imported-model incident (lower of two unreconciled repo figures; range $38-82/day).</a:t>
+              <a:t>Read the map left to right: art store, container Lambda, tables plus vectors. Hosting detail (prod imported in place plus dev mirror, API routes from the ApiGw origin) moves to the next slide; spec recitation stays out of the spoken line. Pre-warm was removed after the 2026-09-23 ~$38/day imported-model incident (lower of two unreconciled repo figures; range $38-82/day).</a:t>
             </a:r>
           </a:p>
         </p:txBody>
@@ -1426,7 +1355,7 @@
           <a:lstStyle/>
           <a:p>
             <a:r>
-              <a:t>Stress the contract: same JSON in CLI, API, and MCP. Callable or not shippable; no mock-as-success anywhere on this surface. Scar (cut-after-rot incident note): bespoke art surfaces rotted and were cut (art band ed785f1, frontier collapsed to one screen plus gated 3d marquee 3f71087); shared forest cap and static fallback remain.</a:t>
+              <a:t>Stress the contract: same JSON in CLI, API, and MCP. Callable or not shippable; no mock-as-success anywhere on this surface. AgentCore detail (6 thin tools over finished units) and hashes in notes only.</a:t>
             </a:r>
           </a:p>
         </p:txBody>
@@ -1496,7 +1425,7 @@
           <a:lstStyle/>
           <a:p>
             <a:r>
-              <a:t>Make the tradeoff explicit: the Gateway cap is fixed, so preview buys immediacy and jobs buy completeness. Scar: prod fell through to the brand floor on a cold-model serial chain past the 22s wall, so the wall went gateway-correct 26s (0147071); never hold a sync call past the wall.</a:t>
+              <a:t>Make the tradeoff explicit: the Gateway cap is fixed, so preview buys immediacy and jobs buy completeness. Past incident (cold-model serial chain past the wall, wall went gateway-correct 26s) in notes. Sync only serves guaranteed fallback tiles; everything real goes through the queue. Transition: each tile costs money. Run: show a cached re-render at 0 invokes.</a:t>
             </a:r>
           </a:p>
         </p:txBody>
@@ -4715,48 +4644,6 @@
       <p:pic>
         <p:nvPicPr>
           <p:cNvPr id="2" name="Picture 1" descr="s14.png"/>
-          <p:cNvPicPr>
-            <a:picLocks noChangeAspect="1"/>
-          </p:cNvPicPr>
-          <p:nvPr/>
-        </p:nvPicPr>
-        <p:blipFill>
-          <a:blip r:embed="rId2"/>
-          <a:stretch>
-            <a:fillRect/>
-          </a:stretch>
-        </p:blipFill>
-        <p:spPr>
-          <a:xfrm>
-            <a:off x="0" y="0"/>
-            <a:ext cx="12191695" cy="6858000"/>
-          </a:xfrm>
-          <a:prstGeom prst="rect">
-            <a:avLst/>
-          </a:prstGeom>
-        </p:spPr>
-      </p:pic>
-    </p:spTree>
-  </p:cSld>
-  <p:clrMapOvr>
-    <a:masterClrMapping/>
-  </p:clrMapOvr>
-</p:sld>
-</file>
-
-<file path=ppt/slides/slide15.xml><?xml version="1.0" encoding="utf-8"?>
-<p:sld xmlns:a="http://schemas.openxmlformats.org/drawingml/2006/main" xmlns:p="http://schemas.openxmlformats.org/presentationml/2006/main" xmlns:r="http://schemas.openxmlformats.org/officeDocument/2006/relationships">
-  <p:cSld>
-    <p:spTree>
-      <p:nvGrpSpPr>
-        <p:cNvPr id="1" name=""/>
-        <p:cNvGrpSpPr/>
-        <p:nvPr/>
-      </p:nvGrpSpPr>
-      <p:grpSpPr/>
-      <p:pic>
-        <p:nvPicPr>
-          <p:cNvPr id="2" name="Picture 1" descr="s15.png"/>
           <p:cNvPicPr>
             <a:picLocks noChangeAspect="1"/>
           </p:cNvPicPr>

</xml_diff>